<commit_message>
fix: close analytics filter and material gaps in original audit tasks
</commit_message>
<xml_diff>
--- a/docs/presentations/leadprocure-az/v3/output/Leadprocure_Data_Sheet_AZ.pptx
+++ b/docs/presentations/leadprocure-az/v3/output/Leadprocure_Data_Sheet_AZ.pptx
@@ -5999,7 +5999,7 @@
               </a:defRPr>
             </a:pPr>
             <a:r>
-              <a:t>Kateqoriya və il üzrə limitlər, tələblərin büdcəyə</a:t>
+              <a:t>AZN ilə şöbə və dövr üzrə büdcələr, plan/fakt və</a:t>
             </a:r>
           </a:p>
         </p:txBody>
@@ -6044,7 +6044,7 @@
               </a:defRPr>
             </a:pPr>
             <a:r>
-              <a:t>təsiri və aşım xəbərdarlıqları görünür. Qəbul edilmiş</a:t>
+              <a:t>aşım nəzarəti. Sazlanmış hədd təsdiqi bloklaya bilər;</a:t>
             </a:r>
           </a:p>
         </p:txBody>
@@ -6089,7 +6089,7 @@
               </a:defRPr>
             </a:pPr>
             <a:r>
-              <a:t>sifarişlər üzrə xərclər valyuta ilə ayrılır; ay sifarişin</a:t>
+              <a:t>administrator istisnası əsaslandırılır. Qəbul edilmiş</a:t>
             </a:r>
           </a:p>
         </p:txBody>
@@ -6134,7 +6134,7 @@
               </a:defRPr>
             </a:pPr>
             <a:r>
-              <a:t>yaradılma tarixinə görə hesablanır.</a:t>
+              <a:t>sifarişlərin xərcləri valyuta və yaranma ayına görə</a:t>
             </a:r>
           </a:p>
         </p:txBody>
@@ -6142,6 +6142,51 @@
       <p:sp>
         <p:nvSpPr>
           <p:cNvPr id="70" name="TextBox 69"/>
+          <p:cNvSpPr txBox="1"/>
+          <p:nvPr/>
+        </p:nvSpPr>
+        <p:spPr>
+          <a:xfrm>
+            <a:off x="3970500" y="8388905"/>
+            <a:ext cx="3068800" cy="201771"/>
+          </a:xfrm>
+          <a:prstGeom prst="rect">
+            <a:avLst/>
+          </a:prstGeom>
+          <a:noFill/>
+        </p:spPr>
+        <p:txBody>
+          <a:bodyPr wrap="none" lIns="0" rIns="0" tIns="0" bIns="0">
+            <a:spAutoFit/>
+          </a:bodyPr>
+          <a:lstStyle/>
+          <a:p>
+            <a:pPr>
+              <a:lnSpc>
+                <a:spcPct val="100000"/>
+              </a:lnSpc>
+              <a:spcBef>
+                <a:spcPts val="0"/>
+              </a:spcBef>
+              <a:spcAft>
+                <a:spcPts val="0"/>
+              </a:spcAft>
+              <a:defRPr b="0" sz="1025">
+                <a:solidFill>
+                  <a:srgbClr val="555555"/>
+                </a:solidFill>
+                <a:latin typeface="IBM Plex Sans"/>
+              </a:defRPr>
+            </a:pPr>
+            <a:r>
+              <a:t>ayrılır.</a:t>
+            </a:r>
+          </a:p>
+        </p:txBody>
+      </p:sp>
+      <p:sp>
+        <p:nvSpPr>
+          <p:cNvPr id="71" name="TextBox 70"/>
           <p:cNvSpPr txBox="1"/>
           <p:nvPr/>
         </p:nvSpPr>
@@ -6186,7 +6231,7 @@
       </p:sp>
       <p:sp>
         <p:nvSpPr>
-          <p:cNvPr id="71" name="TextBox 70"/>
+          <p:cNvPr id="72" name="TextBox 71"/>
           <p:cNvSpPr txBox="1"/>
           <p:nvPr/>
         </p:nvSpPr>
@@ -6231,7 +6276,7 @@
       </p:sp>
       <p:sp>
         <p:nvSpPr>
-          <p:cNvPr id="72" name="TextBox 71"/>
+          <p:cNvPr id="73" name="TextBox 72"/>
           <p:cNvSpPr txBox="1"/>
           <p:nvPr/>
         </p:nvSpPr>
@@ -6276,7 +6321,7 @@
       </p:sp>
       <p:sp>
         <p:nvSpPr>
-          <p:cNvPr id="73" name="TextBox 72"/>
+          <p:cNvPr id="74" name="TextBox 73"/>
           <p:cNvSpPr txBox="1"/>
           <p:nvPr/>
         </p:nvSpPr>
@@ -6321,7 +6366,7 @@
       </p:sp>
       <p:sp>
         <p:nvSpPr>
-          <p:cNvPr id="74" name="TextBox 73"/>
+          <p:cNvPr id="75" name="TextBox 74"/>
           <p:cNvSpPr txBox="1"/>
           <p:nvPr/>
         </p:nvSpPr>
@@ -6366,7 +6411,7 @@
       </p:sp>
       <p:sp>
         <p:nvSpPr>
-          <p:cNvPr id="75" name="TextBox 74"/>
+          <p:cNvPr id="76" name="TextBox 75"/>
           <p:cNvSpPr txBox="1"/>
           <p:nvPr/>
         </p:nvSpPr>
@@ -6411,7 +6456,7 @@
       </p:sp>
       <p:cxnSp>
         <p:nvCxnSpPr>
-          <p:cNvPr id="76" name="Connector 75"/>
+          <p:cNvPr id="77" name="Connector 76"/>
           <p:cNvCxnSpPr/>
           <p:nvPr/>
         </p:nvCxnSpPr>
@@ -6447,7 +6492,7 @@
       </p:cxnSp>
       <p:sp>
         <p:nvSpPr>
-          <p:cNvPr id="77" name="TextBox 76"/>
+          <p:cNvPr id="78" name="TextBox 77"/>
           <p:cNvSpPr txBox="1"/>
           <p:nvPr/>
         </p:nvSpPr>
@@ -6492,7 +6537,7 @@
       </p:sp>
       <p:sp>
         <p:nvSpPr>
-          <p:cNvPr id="78" name="TextBox 77"/>
+          <p:cNvPr id="79" name="TextBox 78"/>
           <p:cNvSpPr txBox="1"/>
           <p:nvPr/>
         </p:nvSpPr>
@@ -6853,7 +6898,7 @@
               </a:defRPr>
             </a:pPr>
             <a:r>
-              <a:t>Alıcı administratoru · Təsdiqləyən şəxs · Alıcı</a:t>
+              <a:t>Alıcı administratoru · Təsdiqləyən şəxs · Maliyyə</a:t>
             </a:r>
           </a:p>
         </p:txBody>
@@ -6898,7 +6943,7 @@
               </a:defRPr>
             </a:pPr>
             <a:r>
-              <a:t>istifadəçisi · Təchizatçı istifadəçisi</a:t>
+              <a:t>əməkdaşı · Alıcı istifadəçisi · Təchizatçı istifadəçisi</a:t>
             </a:r>
           </a:p>
         </p:txBody>
@@ -8926,7 +8971,7 @@
               </a:defRPr>
             </a:pPr>
             <a:r>
-              <a:t>Büdcə aşımı təsdiqi avtomatik bloklamır. Ödəniş statusunun qeydi bank köçürməsi deyil.</a:t>
+              <a:t>Büdcə bloklaması təşkilatın sazladığı həddə bağlıdır. Ödəniş statusunun qeydi bank köçürməsi deyil.</a:t>
             </a:r>
           </a:p>
         </p:txBody>

</xml_diff>